<commit_message>
added auto.bat and some debugging
</commit_message>
<xml_diff>
--- a/template.pptx
+++ b/template.pptx
@@ -7572,7 +7572,7 @@
               <a:buNone/>
             </a:pPr>
             <a:r>
-              <a:rPr lang="en-US" sz="2000" b="1" i="0" u="none" strike="noStrike" cap="none" dirty="0" err="1">
+              <a:rPr lang="en-US" sz="2000" b="1" i="0" u="none" strike="noStrike" cap="none" dirty="0">
                 <a:solidFill>
                   <a:schemeClr val="bg1"/>
                 </a:solidFill>
@@ -7581,19 +7581,7 @@
                 <a:cs typeface="Arial"/>
                 <a:sym typeface="Arial"/>
               </a:rPr>
-              <a:t>Responsarial</a:t>
-            </a:r>
-            <a:r>
-              <a:rPr lang="en-US" sz="2000" b="1" i="0" u="none" strike="noStrike" cap="none" dirty="0">
-                <a:solidFill>
-                  <a:schemeClr val="bg1"/>
-                </a:solidFill>
-                <a:latin typeface="Arial"/>
-                <a:ea typeface="Arial"/>
-                <a:cs typeface="Arial"/>
-                <a:sym typeface="Arial"/>
-              </a:rPr>
-              <a:t> Psalm</a:t>
+              <a:t>Responsorial Psalm</a:t>
             </a:r>
             <a:endParaRPr sz="2000" b="1" i="0" u="none" strike="noStrike" cap="none" dirty="0">
               <a:solidFill>

</xml_diff>